<commit_message>
feat: oficializacao da sigla SILAB (Sistema Integrado de Gestao dos Laboratorios)
</commit_message>
<xml_diff>
--- a/docs/Apresentacao_Gestao_Laboratorios_LASER_SIGEO.pptx
+++ b/docs/Apresentacao_Gestao_Laboratorios_LASER_SIGEO.pptx
@@ -3191,8 +3191,8 @@
         </p:nvSpPr>
         <p:spPr>
           <a:xfrm>
-            <a:off x="1188720" y="1554480"/>
-            <a:ext cx="10058400" cy="3474720"/>
+            <a:off x="1188720" y="1463040"/>
+            <a:ext cx="10058400" cy="3840480"/>
           </a:xfrm>
           <a:prstGeom prst="rect">
             <a:avLst/>
@@ -3207,38 +3207,53 @@
           <a:p>
             <a:pPr>
               <a:spcAft>
-                <a:spcPts val="1200"/>
+                <a:spcPts val="600"/>
               </a:spcAft>
-              <a:defRPr sz="3600" b="1">
+              <a:defRPr sz="4400" b="1">
                 <a:solidFill>
                   <a:srgbClr val="FFFFFF"/>
                 </a:solidFill>
               </a:defRPr>
             </a:pPr>
             <a:r>
-              <a:t>Gestão dos Laboratórios LASER &amp; SIGEO</a:t>
+              <a:t>SILAB</a:t>
             </a:r>
           </a:p>
           <a:p>
             <a:pPr>
               <a:spcAft>
-                <a:spcPts val="2800"/>
+                <a:spcPts val="1400"/>
               </a:spcAft>
-              <a:defRPr sz="1800">
+              <a:defRPr sz="2200" b="1">
+                <a:solidFill>
+                  <a:srgbClr val="60A5FA"/>
+                </a:solidFill>
+              </a:defRPr>
+            </a:pPr>
+            <a:r>
+              <a:t>Sistema Integrado de Gestão dos Laboratórios LASER &amp; SIGEO</a:t>
+            </a:r>
+          </a:p>
+          <a:p>
+            <a:pPr>
+              <a:spcAft>
+                <a:spcPts val="2200"/>
+              </a:spcAft>
+              <a:defRPr sz="1500">
                 <a:solidFill>
                   <a:srgbClr val="94A3B8"/>
                 </a:solidFill>
               </a:defRPr>
             </a:pPr>
             <a:r>
-              <a:t>Plataforma Integrada de Governança de Horários, Equipamentos de Precisão e Suporte Técnico</a:t>
+              <a:t>Governança de Horários, Equipamentos de Precisão, Suporte Técnico e Softwares</a:t>
             </a:r>
           </a:p>
           <a:p>
             <a:pPr>
-              <a:defRPr sz="1300" b="1">
-                <a:solidFill>
-                  <a:srgbClr val="60A5FA"/>
+              <a:defRPr sz="1200" b="1">
+                <a:solidFill>
+                  <a:srgbClr val="93C5FD"/>
                 </a:solidFill>
               </a:defRPr>
             </a:pPr>
@@ -3480,7 +3495,7 @@
               </a:defRPr>
             </a:pPr>
             <a:r>
-              <a:t>GESTAO DOS LABORATORIOS LASER &amp; SIGEO</a:t>
+              <a:t>SILAB • GESTÃO DOS LABORATÓRIOS LASER &amp; SIGEO</a:t>
             </a:r>
           </a:p>
         </p:txBody>
@@ -3905,7 +3920,7 @@
               </a:defRPr>
             </a:pPr>
             <a:r>
-              <a:t>GESTAO DOS LABORATORIOS LASER &amp; SIGEO</a:t>
+              <a:t>SILAB • GESTÃO DOS LABORATÓRIOS LASER &amp; SIGEO</a:t>
             </a:r>
           </a:p>
         </p:txBody>
@@ -4342,7 +4357,7 @@
               </a:defRPr>
             </a:pPr>
             <a:r>
-              <a:t>GESTAO DOS LABORATORIOS LASER &amp; SIGEO</a:t>
+              <a:t>SILAB • GESTÃO DOS LABORATÓRIOS LASER &amp; SIGEO</a:t>
             </a:r>
           </a:p>
         </p:txBody>
@@ -4847,7 +4862,7 @@
               </a:defRPr>
             </a:pPr>
             <a:r>
-              <a:t>GESTAO DOS LABORATORIOS LASER &amp; SIGEO</a:t>
+              <a:t>SILAB • GESTÃO DOS LABORATÓRIOS LASER &amp; SIGEO</a:t>
             </a:r>
           </a:p>
         </p:txBody>
@@ -5194,7 +5209,7 @@
               </a:defRPr>
             </a:pPr>
             <a:r>
-              <a:t>GESTAO DOS LABORATORIOS LASER &amp; SIGEO</a:t>
+              <a:t>SILAB • GESTÃO DOS LABORATÓRIOS LASER &amp; SIGEO</a:t>
             </a:r>
           </a:p>
         </p:txBody>
@@ -5619,7 +5634,7 @@
               </a:defRPr>
             </a:pPr>
             <a:r>
-              <a:t>GESTAO DOS LABORATORIOS LASER &amp; SIGEO</a:t>
+              <a:t>SILAB • GESTÃO DOS LABORATÓRIOS LASER &amp; SIGEO</a:t>
             </a:r>
           </a:p>
         </p:txBody>
@@ -6044,7 +6059,7 @@
               </a:defRPr>
             </a:pPr>
             <a:r>
-              <a:t>GESTAO DOS LABORATORIOS LASER &amp; SIGEO</a:t>
+              <a:t>SILAB • GESTÃO DOS LABORATÓRIOS LASER &amp; SIGEO</a:t>
             </a:r>
           </a:p>
         </p:txBody>
@@ -6399,7 +6414,7 @@
               </a:defRPr>
             </a:pPr>
             <a:r>
-              <a:t>GESTAO DOS LABORATORIOS LASER &amp; SIGEO</a:t>
+              <a:t>SILAB • GESTÃO DOS LABORATÓRIOS LASER &amp; SIGEO</a:t>
             </a:r>
           </a:p>
         </p:txBody>

</xml_diff>